<commit_message>
Organize outputs/ and logs/ by dataset
All prior NCBI Disease runs move into ncbi_disease/ subfolders; the
new BC5CDR and BioRED published-method reproductions land in their
own bc5cdr/ and biored/ subfolders. Updates the one hardcoded path in
measure_hardcoding.py (all its runs are NCBI Disease) to match.

Co-Authored-By: Claude Sonnet 5 <noreply@anthropic.com>
</commit_message>
<xml_diff>
--- a/docs/presentation-revised.pptx
+++ b/docs/presentation-revised.pptx
@@ -4563,7 +4563,7 @@
                 <a:cs typeface="Arial" panose="020B0604020202020204" pitchFamily="34" charset="0"/>
                 <a:sym typeface="Calibri" panose="020F0502020204030204"/>
               </a:rPr>
-              <a:t>This bypasses the need to produce large-scale gold data first</a:t>
+              <a:t>This bypasses the need to produce large-scale gold data first.</a:t>
             </a:r>
             <a:endParaRPr lang="en-US" altLang="en-US" sz="2400" b="0" i="0" u="none" strike="noStrike" cap="none">
               <a:solidFill>
@@ -4600,7 +4600,7 @@
                 <a:cs typeface="Arial" panose="020B0604020202020204" pitchFamily="34" charset="0"/>
                 <a:sym typeface="Calibri" panose="020F0502020204030204"/>
               </a:rPr>
-              <a:t>→ But is the guidelines alone enough to capture every convention?</a:t>
+              <a:t>→ But is the guidelines alone enough to capture enough convention?</a:t>
             </a:r>
             <a:endParaRPr lang="en-US" altLang="en-US" sz="2400" b="0" i="0" u="none" strike="noStrike" cap="none">
               <a:solidFill>
@@ -4637,7 +4637,7 @@
                 <a:cs typeface="Arial" panose="020B0604020202020204" pitchFamily="34" charset="0"/>
                 <a:sym typeface="Calibri" panose="020F0502020204030204"/>
               </a:rPr>
-              <a:t>→ The answer is no, many conventions live only in the gold-labeled data</a:t>
+              <a:t>→ The answer is no, many conventions live only in the gold-labeled data.</a:t>
             </a:r>
             <a:endParaRPr lang="en-US" altLang="en-US" sz="2400">
               <a:solidFill>
@@ -6814,7 +6814,7 @@
         </p:nvGraphicFramePr>
         <p:xfrm>
           <a:off x="1033780" y="4189095"/>
-          <a:ext cx="9842500" cy="1346835"/>
+          <a:ext cx="9842500" cy="1346865"/>
         </p:xfrm>
         <a:graphic>
           <a:graphicData uri="http://schemas.openxmlformats.org/drawingml/2006/table">
@@ -8775,7 +8775,7 @@
         </p:nvGraphicFramePr>
         <p:xfrm>
           <a:off x="1174750" y="2635250"/>
-          <a:ext cx="9842500" cy="1372870"/>
+          <a:ext cx="9842500" cy="1372900"/>
         </p:xfrm>
         <a:graphic>
           <a:graphicData uri="http://schemas.openxmlformats.org/drawingml/2006/table">

</xml_diff>